<commit_message>
feat: Kit Chema v1.0 — cambios del council de dogfooding aplicados
- CHANGELOG: entrada v1.0 (8/8 criterios; notas C.A.2 20/21 y C.A.7 condicional)
- hook anti-secretos: quitado git push del case (no-op tras commit) + docs
- sellos de versión v0.9 -> v1.0 en guion.md y kit-chema.pptx (lámina 1)
- CONTINUAR.md reescrito al estado real (construido y probado)
- README/INSTRUCTIVO: puntero a la web y pegado de CONTEXTO-EMPRESA.md en web
- instalar.sh: omite hooks con aviso si falta python3 (no aborta)
- COMO-PEDIR.md: encabezado de palabras clave suavizado (3 núcleo + 2 convenciones)
- kit-propuestas: veredicto sintetizado con el modelo principal (Fable 5)
- nucleo/CLAUDE.md: fecha de ejemplo -> formato genérico YYYY-MM-DD
- docs/pruebas/aceptacion.md: tabla de los 8 criterios con evidencia

Co-Authored-By: Claude Fable 5 <noreply@anthropic.com>
</commit_message>
<xml_diff>
--- a/presentacion/kit-chema.pptx
+++ b/presentacion/kit-chema.pptx
@@ -2070,7 +2070,7 @@
                 <a:ea typeface="JetBrains Mono" pitchFamily="34" charset="-122"/>
                 <a:cs typeface="JetBrains Mono" pitchFamily="34" charset="-120"/>
               </a:rPr>
-              <a:t>repositorio claude-kit-chema   ·   v0.9   ·   2026-07-09</a:t>
+              <a:t>repositorio claude-kit-chema   ·   v1.0   ·   2026-07-09</a:t>
             </a:r>
             <a:endParaRPr lang="en-US" sz="1100" dirty="0"/>
           </a:p>
@@ -2229,6 +2229,10 @@
             </a:outerShdw>
           </a:effectLst>
         </p:spPr>
+        <p:txBody>
+          <a:bodyPr/>
+          <a:p/>
+        </p:txBody>
       </p:sp>
       <p:sp>
         <p:nvSpPr>
@@ -2249,6 +2253,10 @@
           </a:solidFill>
           <a:ln/>
         </p:spPr>
+        <p:txBody>
+          <a:bodyPr/>
+          <a:p/>
+        </p:txBody>
       </p:sp>
       <p:sp>
         <p:nvSpPr>
@@ -2269,6 +2277,10 @@
           </a:solidFill>
           <a:ln/>
         </p:spPr>
+        <p:txBody>
+          <a:bodyPr/>
+          <a:p/>
+        </p:txBody>
       </p:sp>
       <p:sp>
         <p:nvSpPr>
@@ -2289,6 +2301,10 @@
           </a:solidFill>
           <a:ln/>
         </p:spPr>
+        <p:txBody>
+          <a:bodyPr/>
+          <a:p/>
+        </p:txBody>
       </p:sp>
       <p:sp>
         <p:nvSpPr>
@@ -2517,6 +2533,10 @@
             </a:outerShdw>
           </a:effectLst>
         </p:spPr>
+        <p:txBody>
+          <a:bodyPr/>
+          <a:p/>
+        </p:txBody>
       </p:sp>
       <p:pic>
         <p:nvPicPr>
@@ -2649,6 +2669,10 @@
             </a:outerShdw>
           </a:effectLst>
         </p:spPr>
+        <p:txBody>
+          <a:bodyPr/>
+          <a:p/>
+        </p:txBody>
       </p:sp>
       <p:pic>
         <p:nvPicPr>
@@ -2781,6 +2805,10 @@
             </a:outerShdw>
           </a:effectLst>
         </p:spPr>
+        <p:txBody>
+          <a:bodyPr/>
+          <a:p/>
+        </p:txBody>
       </p:sp>
       <p:pic>
         <p:nvPicPr>
@@ -2909,6 +2937,10 @@
             <a:prstDash val="solid"/>
           </a:ln>
         </p:spPr>
+        <p:txBody>
+          <a:bodyPr/>
+          <a:p/>
+        </p:txBody>
       </p:sp>
       <p:sp>
         <p:nvSpPr>
@@ -3141,6 +3173,10 @@
             </a:outerShdw>
           </a:effectLst>
         </p:spPr>
+        <p:txBody>
+          <a:bodyPr/>
+          <a:p/>
+        </p:txBody>
       </p:sp>
       <p:pic>
         <p:nvPicPr>
@@ -3300,6 +3336,10 @@
             </a:outerShdw>
           </a:effectLst>
         </p:spPr>
+        <p:txBody>
+          <a:bodyPr/>
+          <a:p/>
+        </p:txBody>
       </p:sp>
       <p:pic>
         <p:nvPicPr>
@@ -3459,6 +3499,10 @@
             </a:outerShdw>
           </a:effectLst>
         </p:spPr>
+        <p:txBody>
+          <a:bodyPr/>
+          <a:p/>
+        </p:txBody>
       </p:sp>
       <p:pic>
         <p:nvPicPr>
@@ -3592,6 +3636,10 @@
             <a:prstDash val="solid"/>
           </a:ln>
         </p:spPr>
+        <p:txBody>
+          <a:bodyPr/>
+          <a:p/>
+        </p:txBody>
       </p:sp>
       <p:sp>
         <p:nvSpPr>
@@ -3710,6 +3758,10 @@
             <a:prstDash val="solid"/>
           </a:ln>
         </p:spPr>
+        <p:txBody>
+          <a:bodyPr/>
+          <a:p/>
+        </p:txBody>
       </p:sp>
       <p:sp>
         <p:nvSpPr>
@@ -3947,6 +3999,10 @@
             <a:prstDash val="solid"/>
           </a:ln>
         </p:spPr>
+        <p:txBody>
+          <a:bodyPr/>
+          <a:p/>
+        </p:txBody>
       </p:sp>
       <p:sp>
         <p:nvSpPr>
@@ -3967,6 +4023,10 @@
           </a:solidFill>
           <a:ln/>
         </p:spPr>
+        <p:txBody>
+          <a:bodyPr/>
+          <a:p/>
+        </p:txBody>
       </p:sp>
       <p:sp>
         <p:nvSpPr>
@@ -4073,6 +4133,10 @@
             <a:prstDash val="solid"/>
           </a:ln>
         </p:spPr>
+        <p:txBody>
+          <a:bodyPr/>
+          <a:p/>
+        </p:txBody>
       </p:sp>
       <p:sp>
         <p:nvSpPr>
@@ -4093,6 +4157,10 @@
           </a:solidFill>
           <a:ln/>
         </p:spPr>
+        <p:txBody>
+          <a:bodyPr/>
+          <a:p/>
+        </p:txBody>
       </p:sp>
       <p:sp>
         <p:nvSpPr>
@@ -4199,6 +4267,10 @@
             <a:prstDash val="solid"/>
           </a:ln>
         </p:spPr>
+        <p:txBody>
+          <a:bodyPr/>
+          <a:p/>
+        </p:txBody>
       </p:sp>
       <p:sp>
         <p:nvSpPr>
@@ -4219,6 +4291,10 @@
           </a:solidFill>
           <a:ln/>
         </p:spPr>
+        <p:txBody>
+          <a:bodyPr/>
+          <a:p/>
+        </p:txBody>
       </p:sp>
       <p:sp>
         <p:nvSpPr>
@@ -4404,6 +4480,10 @@
             <a:prstDash val="solid"/>
           </a:ln>
         </p:spPr>
+        <p:txBody>
+          <a:bodyPr/>
+          <a:p/>
+        </p:txBody>
       </p:sp>
       <p:sp>
         <p:nvSpPr>
@@ -4634,6 +4714,10 @@
             <a:prstDash val="solid"/>
           </a:ln>
         </p:spPr>
+        <p:txBody>
+          <a:bodyPr/>
+          <a:p/>
+        </p:txBody>
       </p:sp>
       <p:sp>
         <p:nvSpPr>
@@ -4654,6 +4738,10 @@
           </a:solidFill>
           <a:ln/>
         </p:spPr>
+        <p:txBody>
+          <a:bodyPr/>
+          <a:p/>
+        </p:txBody>
       </p:sp>
       <p:sp>
         <p:nvSpPr>
@@ -4681,6 +4769,10 @@
             </a:outerShdw>
           </a:effectLst>
         </p:spPr>
+        <p:txBody>
+          <a:bodyPr/>
+          <a:p/>
+        </p:txBody>
       </p:sp>
       <p:pic>
         <p:nvPicPr>
@@ -4808,6 +4900,10 @@
             <a:prstDash val="solid"/>
           </a:ln>
         </p:spPr>
+        <p:txBody>
+          <a:bodyPr/>
+          <a:p/>
+        </p:txBody>
       </p:sp>
       <p:sp>
         <p:nvSpPr>
@@ -4828,6 +4924,10 @@
           </a:solidFill>
           <a:ln/>
         </p:spPr>
+        <p:txBody>
+          <a:bodyPr/>
+          <a:p/>
+        </p:txBody>
       </p:sp>
       <p:sp>
         <p:nvSpPr>
@@ -4855,6 +4955,10 @@
             </a:outerShdw>
           </a:effectLst>
         </p:spPr>
+        <p:txBody>
+          <a:bodyPr/>
+          <a:p/>
+        </p:txBody>
       </p:sp>
       <p:pic>
         <p:nvPicPr>
@@ -4982,6 +5086,10 @@
             <a:prstDash val="solid"/>
           </a:ln>
         </p:spPr>
+        <p:txBody>
+          <a:bodyPr/>
+          <a:p/>
+        </p:txBody>
       </p:sp>
       <p:sp>
         <p:nvSpPr>
@@ -5002,6 +5110,10 @@
           </a:solidFill>
           <a:ln/>
         </p:spPr>
+        <p:txBody>
+          <a:bodyPr/>
+          <a:p/>
+        </p:txBody>
       </p:sp>
       <p:sp>
         <p:nvSpPr>
@@ -5029,6 +5141,10 @@
             </a:outerShdw>
           </a:effectLst>
         </p:spPr>
+        <p:txBody>
+          <a:bodyPr/>
+          <a:p/>
+        </p:txBody>
       </p:sp>
       <p:pic>
         <p:nvPicPr>
@@ -5156,6 +5272,10 @@
             <a:prstDash val="solid"/>
           </a:ln>
         </p:spPr>
+        <p:txBody>
+          <a:bodyPr/>
+          <a:p/>
+        </p:txBody>
       </p:sp>
       <p:sp>
         <p:nvSpPr>
@@ -5176,6 +5296,10 @@
           </a:solidFill>
           <a:ln/>
         </p:spPr>
+        <p:txBody>
+          <a:bodyPr/>
+          <a:p/>
+        </p:txBody>
       </p:sp>
       <p:sp>
         <p:nvSpPr>
@@ -5203,6 +5327,10 @@
             </a:outerShdw>
           </a:effectLst>
         </p:spPr>
+        <p:txBody>
+          <a:bodyPr/>
+          <a:p/>
+        </p:txBody>
       </p:sp>
       <p:pic>
         <p:nvPicPr>
@@ -5330,6 +5458,10 @@
             <a:prstDash val="solid"/>
           </a:ln>
         </p:spPr>
+        <p:txBody>
+          <a:bodyPr/>
+          <a:p/>
+        </p:txBody>
       </p:sp>
       <p:sp>
         <p:nvSpPr>
@@ -5350,6 +5482,10 @@
           </a:solidFill>
           <a:ln/>
         </p:spPr>
+        <p:txBody>
+          <a:bodyPr/>
+          <a:p/>
+        </p:txBody>
       </p:sp>
       <p:sp>
         <p:nvSpPr>
@@ -5377,6 +5513,10 @@
             </a:outerShdw>
           </a:effectLst>
         </p:spPr>
+        <p:txBody>
+          <a:bodyPr/>
+          <a:p/>
+        </p:txBody>
       </p:sp>
       <p:pic>
         <p:nvPicPr>
@@ -5502,6 +5642,10 @@
             <a:prstDash val="solid"/>
           </a:ln>
         </p:spPr>
+        <p:txBody>
+          <a:bodyPr/>
+          <a:p/>
+        </p:txBody>
       </p:sp>
       <p:sp>
         <p:nvSpPr>
@@ -5739,6 +5883,10 @@
             </a:outerShdw>
           </a:effectLst>
         </p:spPr>
+        <p:txBody>
+          <a:bodyPr/>
+          <a:p/>
+        </p:txBody>
       </p:sp>
       <p:sp>
         <p:nvSpPr>
@@ -5766,6 +5914,10 @@
             </a:outerShdw>
           </a:effectLst>
         </p:spPr>
+        <p:txBody>
+          <a:bodyPr/>
+          <a:p/>
+        </p:txBody>
       </p:sp>
       <p:pic>
         <p:nvPicPr>
@@ -5903,6 +6055,10 @@
             </a:outerShdw>
           </a:effectLst>
         </p:spPr>
+        <p:txBody>
+          <a:bodyPr/>
+          <a:p/>
+        </p:txBody>
       </p:sp>
       <p:sp>
         <p:nvSpPr>
@@ -5930,6 +6086,10 @@
             </a:outerShdw>
           </a:effectLst>
         </p:spPr>
+        <p:txBody>
+          <a:bodyPr/>
+          <a:p/>
+        </p:txBody>
       </p:sp>
       <p:pic>
         <p:nvPicPr>
@@ -6067,6 +6227,10 @@
             </a:outerShdw>
           </a:effectLst>
         </p:spPr>
+        <p:txBody>
+          <a:bodyPr/>
+          <a:p/>
+        </p:txBody>
       </p:sp>
       <p:sp>
         <p:nvSpPr>
@@ -6094,6 +6258,10 @@
             </a:outerShdw>
           </a:effectLst>
         </p:spPr>
+        <p:txBody>
+          <a:bodyPr/>
+          <a:p/>
+        </p:txBody>
       </p:sp>
       <p:pic>
         <p:nvPicPr>
@@ -6231,6 +6399,10 @@
             </a:outerShdw>
           </a:effectLst>
         </p:spPr>
+        <p:txBody>
+          <a:bodyPr/>
+          <a:p/>
+        </p:txBody>
       </p:sp>
       <p:sp>
         <p:nvSpPr>
@@ -6258,6 +6430,10 @@
             </a:outerShdw>
           </a:effectLst>
         </p:spPr>
+        <p:txBody>
+          <a:bodyPr/>
+          <a:p/>
+        </p:txBody>
       </p:sp>
       <p:pic>
         <p:nvPicPr>
@@ -6386,6 +6562,10 @@
             <a:prstDash val="solid"/>
           </a:ln>
         </p:spPr>
+        <p:txBody>
+          <a:bodyPr/>
+          <a:p/>
+        </p:txBody>
       </p:sp>
       <p:sp>
         <p:nvSpPr>
@@ -6618,6 +6798,10 @@
             </a:outerShdw>
           </a:effectLst>
         </p:spPr>
+        <p:txBody>
+          <a:bodyPr/>
+          <a:p/>
+        </p:txBody>
       </p:sp>
       <p:pic>
         <p:nvPicPr>
@@ -6662,6 +6846,10 @@
           </a:solidFill>
           <a:ln/>
         </p:spPr>
+        <p:txBody>
+          <a:bodyPr/>
+          <a:p/>
+        </p:txBody>
       </p:sp>
       <p:sp>
         <p:nvSpPr>
@@ -6836,6 +7024,10 @@
             </a:outerShdw>
           </a:effectLst>
         </p:spPr>
+        <p:txBody>
+          <a:bodyPr/>
+          <a:p/>
+        </p:txBody>
       </p:sp>
       <p:pic>
         <p:nvPicPr>
@@ -6880,6 +7072,10 @@
           </a:solidFill>
           <a:ln/>
         </p:spPr>
+        <p:txBody>
+          <a:bodyPr/>
+          <a:p/>
+        </p:txBody>
       </p:sp>
       <p:sp>
         <p:nvSpPr>
@@ -7054,6 +7250,10 @@
             </a:outerShdw>
           </a:effectLst>
         </p:spPr>
+        <p:txBody>
+          <a:bodyPr/>
+          <a:p/>
+        </p:txBody>
       </p:sp>
       <p:pic>
         <p:nvPicPr>
@@ -7098,6 +7298,10 @@
           </a:solidFill>
           <a:ln/>
         </p:spPr>
+        <p:txBody>
+          <a:bodyPr/>
+          <a:p/>
+        </p:txBody>
       </p:sp>
       <p:sp>
         <p:nvSpPr>
@@ -7272,6 +7476,10 @@
             </a:outerShdw>
           </a:effectLst>
         </p:spPr>
+        <p:txBody>
+          <a:bodyPr/>
+          <a:p/>
+        </p:txBody>
       </p:sp>
       <p:pic>
         <p:nvPicPr>
@@ -7316,6 +7524,10 @@
           </a:solidFill>
           <a:ln/>
         </p:spPr>
+        <p:txBody>
+          <a:bodyPr/>
+          <a:p/>
+        </p:txBody>
       </p:sp>
       <p:sp>
         <p:nvSpPr>
@@ -7462,6 +7674,10 @@
             <a:prstDash val="solid"/>
           </a:ln>
         </p:spPr>
+        <p:txBody>
+          <a:bodyPr/>
+          <a:p/>
+        </p:txBody>
       </p:sp>
       <p:sp>
         <p:nvSpPr>
@@ -8863,6 +9079,10 @@
             <a:prstDash val="solid"/>
           </a:ln>
         </p:spPr>
+        <p:txBody>
+          <a:bodyPr/>
+          <a:p/>
+        </p:txBody>
       </p:sp>
       <p:sp>
         <p:nvSpPr>
@@ -9375,6 +9595,10 @@
             <a:prstDash val="solid"/>
           </a:ln>
         </p:spPr>
+        <p:txBody>
+          <a:bodyPr/>
+          <a:p/>
+        </p:txBody>
       </p:sp>
       <p:pic>
         <p:nvPicPr>
@@ -9463,6 +9687,10 @@
             <a:prstDash val="solid"/>
           </a:ln>
         </p:spPr>
+        <p:txBody>
+          <a:bodyPr/>
+          <a:p/>
+        </p:txBody>
       </p:sp>
       <p:pic>
         <p:nvPicPr>
@@ -9551,6 +9779,10 @@
             <a:prstDash val="solid"/>
           </a:ln>
         </p:spPr>
+        <p:txBody>
+          <a:bodyPr/>
+          <a:p/>
+        </p:txBody>
       </p:sp>
       <p:pic>
         <p:nvPicPr>
@@ -9641,6 +9873,10 @@
             </a:outerShdw>
           </a:effectLst>
         </p:spPr>
+        <p:txBody>
+          <a:bodyPr/>
+          <a:p/>
+        </p:txBody>
       </p:sp>
       <p:pic>
         <p:nvPicPr>
@@ -9769,6 +10005,10 @@
             <a:prstDash val="solid"/>
           </a:ln>
         </p:spPr>
+        <p:txBody>
+          <a:bodyPr/>
+          <a:p/>
+        </p:txBody>
       </p:sp>
       <p:sp>
         <p:nvSpPr>
@@ -9999,6 +10239,10 @@
             <a:prstDash val="solid"/>
           </a:ln>
         </p:spPr>
+        <p:txBody>
+          <a:bodyPr/>
+          <a:p/>
+        </p:txBody>
       </p:sp>
       <p:sp>
         <p:nvSpPr>
@@ -10019,6 +10263,10 @@
           </a:solidFill>
           <a:ln/>
         </p:spPr>
+        <p:txBody>
+          <a:bodyPr/>
+          <a:p/>
+        </p:txBody>
       </p:sp>
       <p:sp>
         <p:nvSpPr>
@@ -10164,6 +10412,10 @@
             <a:prstDash val="solid"/>
           </a:ln>
         </p:spPr>
+        <p:txBody>
+          <a:bodyPr/>
+          <a:p/>
+        </p:txBody>
       </p:sp>
       <p:sp>
         <p:nvSpPr>
@@ -10184,6 +10436,10 @@
           </a:solidFill>
           <a:ln/>
         </p:spPr>
+        <p:txBody>
+          <a:bodyPr/>
+          <a:p/>
+        </p:txBody>
       </p:sp>
       <p:sp>
         <p:nvSpPr>
@@ -10329,6 +10585,10 @@
             <a:prstDash val="solid"/>
           </a:ln>
         </p:spPr>
+        <p:txBody>
+          <a:bodyPr/>
+          <a:p/>
+        </p:txBody>
       </p:sp>
       <p:sp>
         <p:nvSpPr>
@@ -10349,6 +10609,10 @@
           </a:solidFill>
           <a:ln/>
         </p:spPr>
+        <p:txBody>
+          <a:bodyPr/>
+          <a:p/>
+        </p:txBody>
       </p:sp>
       <p:sp>
         <p:nvSpPr>
@@ -10494,6 +10758,10 @@
             <a:prstDash val="solid"/>
           </a:ln>
         </p:spPr>
+        <p:txBody>
+          <a:bodyPr/>
+          <a:p/>
+        </p:txBody>
       </p:sp>
       <p:sp>
         <p:nvSpPr>
@@ -10514,6 +10782,10 @@
           </a:solidFill>
           <a:ln/>
         </p:spPr>
+        <p:txBody>
+          <a:bodyPr/>
+          <a:p/>
+        </p:txBody>
       </p:sp>
       <p:sp>
         <p:nvSpPr>
@@ -10659,6 +10931,10 @@
             <a:prstDash val="solid"/>
           </a:ln>
         </p:spPr>
+        <p:txBody>
+          <a:bodyPr/>
+          <a:p/>
+        </p:txBody>
       </p:sp>
       <p:sp>
         <p:nvSpPr>
@@ -10679,6 +10955,10 @@
           </a:solidFill>
           <a:ln/>
         </p:spPr>
+        <p:txBody>
+          <a:bodyPr/>
+          <a:p/>
+        </p:txBody>
       </p:sp>
       <p:sp>
         <p:nvSpPr>
@@ -10824,6 +11104,10 @@
             <a:prstDash val="solid"/>
           </a:ln>
         </p:spPr>
+        <p:txBody>
+          <a:bodyPr/>
+          <a:p/>
+        </p:txBody>
       </p:sp>
       <p:sp>
         <p:nvSpPr>
@@ -10844,6 +11128,10 @@
           </a:solidFill>
           <a:ln/>
         </p:spPr>
+        <p:txBody>
+          <a:bodyPr/>
+          <a:p/>
+        </p:txBody>
       </p:sp>
       <p:sp>
         <p:nvSpPr>
@@ -10987,6 +11275,10 @@
             <a:prstDash val="solid"/>
           </a:ln>
         </p:spPr>
+        <p:txBody>
+          <a:bodyPr/>
+          <a:p/>
+        </p:txBody>
       </p:sp>
       <p:sp>
         <p:nvSpPr>
@@ -11258,6 +11550,10 @@
             <a:prstDash val="solid"/>
           </a:ln>
         </p:spPr>
+        <p:txBody>
+          <a:bodyPr/>
+          <a:p/>
+        </p:txBody>
       </p:sp>
       <p:sp>
         <p:nvSpPr>
@@ -11278,6 +11574,10 @@
           </a:solidFill>
           <a:ln/>
         </p:spPr>
+        <p:txBody>
+          <a:bodyPr/>
+          <a:p/>
+        </p:txBody>
       </p:sp>
       <p:sp>
         <p:nvSpPr>
@@ -11344,6 +11644,10 @@
             <a:prstDash val="solid"/>
           </a:ln>
         </p:spPr>
+        <p:txBody>
+          <a:bodyPr/>
+          <a:p/>
+        </p:txBody>
       </p:sp>
       <p:sp>
         <p:nvSpPr>
@@ -11364,6 +11668,10 @@
           </a:solidFill>
           <a:ln/>
         </p:spPr>
+        <p:txBody>
+          <a:bodyPr/>
+          <a:p/>
+        </p:txBody>
       </p:sp>
       <p:sp>
         <p:nvSpPr>
@@ -11430,6 +11738,10 @@
             <a:prstDash val="solid"/>
           </a:ln>
         </p:spPr>
+        <p:txBody>
+          <a:bodyPr/>
+          <a:p/>
+        </p:txBody>
       </p:sp>
       <p:sp>
         <p:nvSpPr>
@@ -11450,6 +11762,10 @@
           </a:solidFill>
           <a:ln/>
         </p:spPr>
+        <p:txBody>
+          <a:bodyPr/>
+          <a:p/>
+        </p:txBody>
       </p:sp>
       <p:sp>
         <p:nvSpPr>
@@ -11516,6 +11832,10 @@
             <a:prstDash val="solid"/>
           </a:ln>
         </p:spPr>
+        <p:txBody>
+          <a:bodyPr/>
+          <a:p/>
+        </p:txBody>
       </p:sp>
       <p:sp>
         <p:nvSpPr>
@@ -11536,6 +11856,10 @@
           </a:solidFill>
           <a:ln/>
         </p:spPr>
+        <p:txBody>
+          <a:bodyPr/>
+          <a:p/>
+        </p:txBody>
       </p:sp>
       <p:sp>
         <p:nvSpPr>
@@ -11602,6 +11926,10 @@
             <a:prstDash val="solid"/>
           </a:ln>
         </p:spPr>
+        <p:txBody>
+          <a:bodyPr/>
+          <a:p/>
+        </p:txBody>
       </p:sp>
       <p:sp>
         <p:nvSpPr>
@@ -11622,6 +11950,10 @@
           </a:solidFill>
           <a:ln/>
         </p:spPr>
+        <p:txBody>
+          <a:bodyPr/>
+          <a:p/>
+        </p:txBody>
       </p:sp>
       <p:sp>
         <p:nvSpPr>
@@ -11688,6 +12020,10 @@
             <a:prstDash val="solid"/>
           </a:ln>
         </p:spPr>
+        <p:txBody>
+          <a:bodyPr/>
+          <a:p/>
+        </p:txBody>
       </p:sp>
       <p:sp>
         <p:nvSpPr>
@@ -11708,6 +12044,10 @@
           </a:solidFill>
           <a:ln/>
         </p:spPr>
+        <p:txBody>
+          <a:bodyPr/>
+          <a:p/>
+        </p:txBody>
       </p:sp>
       <p:sp>
         <p:nvSpPr>
@@ -11860,6 +12200,10 @@
             </a:outerShdw>
           </a:effectLst>
         </p:spPr>
+        <p:txBody>
+          <a:bodyPr/>
+          <a:p/>
+        </p:txBody>
       </p:sp>
       <p:sp>
         <p:nvSpPr>
@@ -11880,6 +12224,10 @@
           </a:solidFill>
           <a:ln/>
         </p:spPr>
+        <p:txBody>
+          <a:bodyPr/>
+          <a:p/>
+        </p:txBody>
       </p:sp>
       <p:sp>
         <p:nvSpPr>
@@ -11902,6 +12250,10 @@
           </a:solidFill>
           <a:ln/>
         </p:spPr>
+        <p:txBody>
+          <a:bodyPr/>
+          <a:p/>
+        </p:txBody>
       </p:sp>
       <p:sp>
         <p:nvSpPr>
@@ -12015,6 +12367,10 @@
             </a:outerShdw>
           </a:effectLst>
         </p:spPr>
+        <p:txBody>
+          <a:bodyPr/>
+          <a:p/>
+        </p:txBody>
       </p:sp>
       <p:sp>
         <p:nvSpPr>
@@ -12035,6 +12391,10 @@
           </a:solidFill>
           <a:ln/>
         </p:spPr>
+        <p:txBody>
+          <a:bodyPr/>
+          <a:p/>
+        </p:txBody>
       </p:sp>
       <p:sp>
         <p:nvSpPr>
@@ -12057,6 +12417,10 @@
           </a:solidFill>
           <a:ln/>
         </p:spPr>
+        <p:txBody>
+          <a:bodyPr/>
+          <a:p/>
+        </p:txBody>
       </p:sp>
       <p:sp>
         <p:nvSpPr>
@@ -12161,6 +12525,10 @@
             <a:prstDash val="solid"/>
           </a:ln>
         </p:spPr>
+        <p:txBody>
+          <a:bodyPr/>
+          <a:p/>
+        </p:txBody>
       </p:sp>
       <p:sp>
         <p:nvSpPr>
@@ -12398,6 +12766,10 @@
             </a:outerShdw>
           </a:effectLst>
         </p:spPr>
+        <p:txBody>
+          <a:bodyPr/>
+          <a:p/>
+        </p:txBody>
       </p:sp>
       <p:sp>
         <p:nvSpPr>
@@ -12418,6 +12790,10 @@
           </a:solidFill>
           <a:ln/>
         </p:spPr>
+        <p:txBody>
+          <a:bodyPr/>
+          <a:p/>
+        </p:txBody>
       </p:sp>
       <p:sp>
         <p:nvSpPr>
@@ -12612,6 +12988,10 @@
             </a:outerShdw>
           </a:effectLst>
         </p:spPr>
+        <p:txBody>
+          <a:bodyPr/>
+          <a:p/>
+        </p:txBody>
       </p:sp>
       <p:sp>
         <p:nvSpPr>
@@ -12632,6 +13012,10 @@
           </a:solidFill>
           <a:ln/>
         </p:spPr>
+        <p:txBody>
+          <a:bodyPr/>
+          <a:p/>
+        </p:txBody>
       </p:sp>
       <p:sp>
         <p:nvSpPr>
@@ -12856,6 +13240,10 @@
             <a:prstDash val="solid"/>
           </a:ln>
         </p:spPr>
+        <p:txBody>
+          <a:bodyPr/>
+          <a:p/>
+        </p:txBody>
       </p:sp>
       <p:sp>
         <p:nvSpPr>

</xml_diff>

<commit_message>
fix: minors de la revisión final (deck, referencias, README, portabilidad, alcance del hook)
Co-Authored-By: Claude Fable 5 <noreply@anthropic.com>
</commit_message>
<xml_diff>
--- a/presentacion/kit-chema.pptx
+++ b/presentacion/kit-chema.pptx
@@ -1856,7 +1856,7 @@
       </p:grpSpPr>
       <p:pic>
         <p:nvPicPr>
-          <p:cNvPr id="2" name="Image 0" descr="preencoded.png">    </p:cNvPr>
+          <p:cNvPr id="2" name="Image 0" descr="preencoded.png"/>
           <p:cNvPicPr>
             <a:picLocks noChangeAspect="1"/>
           </p:cNvPicPr>
@@ -2155,7 +2155,7 @@
                 <a:ea typeface="JetBrains Mono" pitchFamily="34" charset="-122"/>
                 <a:cs typeface="JetBrains Mono" pitchFamily="34" charset="-120"/>
               </a:rPr>
-              <a:t>   Instalación</a:t>
+              <a:t xml:space="preserve">   Instalación</a:t>
             </a:r>
             <a:endParaRPr lang="en-US" sz="1200" dirty="0"/>
           </a:p>
@@ -2339,7 +2339,7 @@
                 <a:ea typeface="JetBrains Mono" pitchFamily="34" charset="-122"/>
                 <a:cs typeface="JetBrains Mono" pitchFamily="34" charset="-120"/>
               </a:rPr>
-              <a:t>$ </a:t>
+              <a:t xml:space="preserve">$ </a:t>
             </a:r>
             <a:pPr algn="l" indent="0" marL="0">
               <a:buNone/>
@@ -2392,7 +2392,7 @@
                 <a:ea typeface="JetBrains Mono" pitchFamily="34" charset="-122"/>
                 <a:cs typeface="JetBrains Mono" pitchFamily="34" charset="-120"/>
               </a:rPr>
-              <a:t>$ </a:t>
+              <a:t xml:space="preserve">$ </a:t>
             </a:r>
             <a:pPr algn="l" indent="0" marL="0">
               <a:buNone/>
@@ -2445,7 +2445,7 @@
                 <a:ea typeface="JetBrains Mono" pitchFamily="34" charset="-122"/>
                 <a:cs typeface="JetBrains Mono" pitchFamily="34" charset="-120"/>
               </a:rPr>
-              <a:t>$ </a:t>
+              <a:t xml:space="preserve">$ </a:t>
             </a:r>
             <a:pPr algn="l" indent="0" marL="0">
               <a:buNone/>
@@ -2540,7 +2540,7 @@
       </p:sp>
       <p:pic>
         <p:nvPicPr>
-          <p:cNvPr id="13" name="Image 0" descr="preencoded.png">    </p:cNvPr>
+          <p:cNvPr id="13" name="Image 0" descr="preencoded.png"/>
           <p:cNvPicPr>
             <a:picLocks noChangeAspect="1"/>
           </p:cNvPicPr>
@@ -2637,7 +2637,7 @@
                 <a:ea typeface="Inter" pitchFamily="34" charset="-122"/>
                 <a:cs typeface="Inter" pitchFamily="34" charset="-120"/>
               </a:rPr>
-              <a:t>Si ya tienes un ~/.claude/CLAUDE.md, añade una sección marcada al final y respalda el anterior.</a:t>
+              <a:t>Si ya tienes un ~/.claude/CLAUDE.md, añade una sección marcada al final sin tocar lo tuyo; en actualizaciones respalda antes de reescribirla.</a:t>
             </a:r>
             <a:endParaRPr lang="en-US" sz="1250" dirty="0"/>
           </a:p>
@@ -2676,7 +2676,7 @@
       </p:sp>
       <p:pic>
         <p:nvPicPr>
-          <p:cNvPr id="17" name="Image 1" descr="preencoded.png">    </p:cNvPr>
+          <p:cNvPr id="17" name="Image 1" descr="preencoded.png"/>
           <p:cNvPicPr>
             <a:picLocks noChangeAspect="1"/>
           </p:cNvPicPr>
@@ -2812,7 +2812,7 @@
       </p:sp>
       <p:pic>
         <p:nvPicPr>
-          <p:cNvPr id="21" name="Image 2" descr="preencoded.png">    </p:cNvPr>
+          <p:cNvPr id="21" name="Image 2" descr="preencoded.png"/>
           <p:cNvPicPr>
             <a:picLocks noChangeAspect="1"/>
           </p:cNvPicPr>
@@ -3099,7 +3099,7 @@
                 <a:ea typeface="JetBrains Mono" pitchFamily="34" charset="-122"/>
                 <a:cs typeface="JetBrains Mono" pitchFamily="34" charset="-120"/>
               </a:rPr>
-              <a:t>   Mejora continua</a:t>
+              <a:t xml:space="preserve">   Mejora continua</a:t>
             </a:r>
             <a:endParaRPr lang="en-US" sz="1200" dirty="0"/>
           </a:p>
@@ -3180,7 +3180,7 @@
       </p:sp>
       <p:pic>
         <p:nvPicPr>
-          <p:cNvPr id="5" name="Image 0" descr="preencoded.png">    </p:cNvPr>
+          <p:cNvPr id="5" name="Image 0" descr="preencoded.png"/>
           <p:cNvPicPr>
             <a:picLocks noChangeAspect="1"/>
           </p:cNvPicPr>
@@ -3288,7 +3288,7 @@
       </p:sp>
       <p:pic>
         <p:nvPicPr>
-          <p:cNvPr id="8" name="Image 1" descr="preencoded.png">    </p:cNvPr>
+          <p:cNvPr id="8" name="Image 1" descr="preencoded.png"/>
           <p:cNvPicPr>
             <a:picLocks noChangeAspect="1"/>
           </p:cNvPicPr>
@@ -3343,7 +3343,7 @@
       </p:sp>
       <p:pic>
         <p:nvPicPr>
-          <p:cNvPr id="10" name="Image 2" descr="preencoded.png">    </p:cNvPr>
+          <p:cNvPr id="10" name="Image 2" descr="preencoded.png"/>
           <p:cNvPicPr>
             <a:picLocks noChangeAspect="1"/>
           </p:cNvPicPr>
@@ -3451,7 +3451,7 @@
       </p:sp>
       <p:pic>
         <p:nvPicPr>
-          <p:cNvPr id="13" name="Image 3" descr="preencoded.png">    </p:cNvPr>
+          <p:cNvPr id="13" name="Image 3" descr="preencoded.png"/>
           <p:cNvPicPr>
             <a:picLocks noChangeAspect="1"/>
           </p:cNvPicPr>
@@ -3506,7 +3506,7 @@
       </p:sp>
       <p:pic>
         <p:nvPicPr>
-          <p:cNvPr id="15" name="Image 4" descr="preencoded.png">    </p:cNvPr>
+          <p:cNvPr id="15" name="Image 4" descr="preencoded.png"/>
           <p:cNvPicPr>
             <a:picLocks noChangeAspect="1"/>
           </p:cNvPicPr>
@@ -3674,7 +3674,7 @@
                 <a:ea typeface="JetBrains Mono" pitchFamily="34" charset="-122"/>
                 <a:cs typeface="JetBrains Mono" pitchFamily="34" charset="-120"/>
               </a:rPr>
-              <a:t>$ </a:t>
+              <a:t xml:space="preserve">$ </a:t>
             </a:r>
             <a:pPr algn="l" indent="0" marL="0">
               <a:buNone/>
@@ -3875,7 +3875,7 @@
       </p:grpSpPr>
       <p:pic>
         <p:nvPicPr>
-          <p:cNvPr id="2" name="Image 0" descr="preencoded.png">    </p:cNvPr>
+          <p:cNvPr id="2" name="Image 0" descr="preencoded.png"/>
           <p:cNvPicPr>
             <a:picLocks noChangeAspect="1"/>
           </p:cNvPicPr>
@@ -4410,7 +4410,7 @@
                 <a:ea typeface="Inter" pitchFamily="34" charset="-122"/>
                 <a:cs typeface="Inter" pitchFamily="34" charset="-120"/>
               </a:rPr>
-              <a:t>Instálalo hoy:   </a:t>
+              <a:t xml:space="preserve">Instálalo hoy:   </a:t>
             </a:r>
             <a:pPr algn="ctr" indent="0" marL="0">
               <a:buNone/>
@@ -4438,7 +4438,7 @@
                 <a:ea typeface="Inter" pitchFamily="34" charset="-122"/>
                 <a:cs typeface="Inter" pitchFamily="34" charset="-120"/>
               </a:rPr>
-              <a:t>  +  </a:t>
+              <a:t xml:space="preserve">  +  </a:t>
             </a:r>
             <a:pPr algn="ctr" indent="0" marL="0">
               <a:buNone/>
@@ -4642,7 +4642,7 @@
                 <a:ea typeface="JetBrains Mono" pitchFamily="34" charset="-122"/>
                 <a:cs typeface="JetBrains Mono" pitchFamily="34" charset="-120"/>
               </a:rPr>
-              <a:t>   El problema</a:t>
+              <a:t xml:space="preserve">   El problema</a:t>
             </a:r>
             <a:endParaRPr lang="en-US" sz="1200" dirty="0"/>
           </a:p>
@@ -4776,7 +4776,7 @@
       </p:sp>
       <p:pic>
         <p:nvPicPr>
-          <p:cNvPr id="7" name="Image 0" descr="preencoded.png">    </p:cNvPr>
+          <p:cNvPr id="7" name="Image 0" descr="preencoded.png"/>
           <p:cNvPicPr>
             <a:picLocks noChangeAspect="1"/>
           </p:cNvPicPr>
@@ -4962,7 +4962,7 @@
       </p:sp>
       <p:pic>
         <p:nvPicPr>
-          <p:cNvPr id="13" name="Image 1" descr="preencoded.png">    </p:cNvPr>
+          <p:cNvPr id="13" name="Image 1" descr="preencoded.png"/>
           <p:cNvPicPr>
             <a:picLocks noChangeAspect="1"/>
           </p:cNvPicPr>
@@ -5148,7 +5148,7 @@
       </p:sp>
       <p:pic>
         <p:nvPicPr>
-          <p:cNvPr id="19" name="Image 2" descr="preencoded.png">    </p:cNvPr>
+          <p:cNvPr id="19" name="Image 2" descr="preencoded.png"/>
           <p:cNvPicPr>
             <a:picLocks noChangeAspect="1"/>
           </p:cNvPicPr>
@@ -5334,7 +5334,7 @@
       </p:sp>
       <p:pic>
         <p:nvPicPr>
-          <p:cNvPr id="25" name="Image 3" descr="preencoded.png">    </p:cNvPr>
+          <p:cNvPr id="25" name="Image 3" descr="preencoded.png"/>
           <p:cNvPicPr>
             <a:picLocks noChangeAspect="1"/>
           </p:cNvPicPr>
@@ -5520,7 +5520,7 @@
       </p:sp>
       <p:pic>
         <p:nvPicPr>
-          <p:cNvPr id="31" name="Image 4" descr="preencoded.png">    </p:cNvPr>
+          <p:cNvPr id="31" name="Image 4" descr="preencoded.png"/>
           <p:cNvPicPr>
             <a:picLocks noChangeAspect="1"/>
           </p:cNvPicPr>
@@ -5804,7 +5804,7 @@
                 <a:ea typeface="JetBrains Mono" pitchFamily="34" charset="-122"/>
                 <a:cs typeface="JetBrains Mono" pitchFamily="34" charset="-120"/>
               </a:rPr>
-              <a:t>   La solución</a:t>
+              <a:t xml:space="preserve">   La solución</a:t>
             </a:r>
             <a:endParaRPr lang="en-US" sz="1200" dirty="0"/>
           </a:p>
@@ -5921,7 +5921,7 @@
       </p:sp>
       <p:pic>
         <p:nvPicPr>
-          <p:cNvPr id="6" name="Image 0" descr="preencoded.png">    </p:cNvPr>
+          <p:cNvPr id="6" name="Image 0" descr="preencoded.png"/>
           <p:cNvPicPr>
             <a:picLocks noChangeAspect="1"/>
           </p:cNvPicPr>
@@ -6093,7 +6093,7 @@
       </p:sp>
       <p:pic>
         <p:nvPicPr>
-          <p:cNvPr id="11" name="Image 1" descr="preencoded.png">    </p:cNvPr>
+          <p:cNvPr id="11" name="Image 1" descr="preencoded.png"/>
           <p:cNvPicPr>
             <a:picLocks noChangeAspect="1"/>
           </p:cNvPicPr>
@@ -6265,7 +6265,7 @@
       </p:sp>
       <p:pic>
         <p:nvPicPr>
-          <p:cNvPr id="16" name="Image 2" descr="preencoded.png">    </p:cNvPr>
+          <p:cNvPr id="16" name="Image 2" descr="preencoded.png"/>
           <p:cNvPicPr>
             <a:picLocks noChangeAspect="1"/>
           </p:cNvPicPr>
@@ -6437,7 +6437,7 @@
       </p:sp>
       <p:pic>
         <p:nvPicPr>
-          <p:cNvPr id="21" name="Image 3" descr="preencoded.png">    </p:cNvPr>
+          <p:cNvPr id="21" name="Image 3" descr="preencoded.png"/>
           <p:cNvPicPr>
             <a:picLocks noChangeAspect="1"/>
           </p:cNvPicPr>
@@ -6724,7 +6724,7 @@
                 <a:ea typeface="JetBrains Mono" pitchFamily="34" charset="-122"/>
                 <a:cs typeface="JetBrains Mono" pitchFamily="34" charset="-120"/>
               </a:rPr>
-              <a:t>   En cada conversación</a:t>
+              <a:t xml:space="preserve">   En cada conversación</a:t>
             </a:r>
             <a:endParaRPr lang="en-US" sz="1200" dirty="0"/>
           </a:p>
@@ -6805,7 +6805,7 @@
       </p:sp>
       <p:pic>
         <p:nvPicPr>
-          <p:cNvPr id="5" name="Image 0" descr="preencoded.png">    </p:cNvPr>
+          <p:cNvPr id="5" name="Image 0" descr="preencoded.png"/>
           <p:cNvPicPr>
             <a:picLocks noChangeAspect="1"/>
           </p:cNvPicPr>
@@ -6976,7 +6976,7 @@
       </p:sp>
       <p:pic>
         <p:nvPicPr>
-          <p:cNvPr id="10" name="Image 1" descr="preencoded.png">    </p:cNvPr>
+          <p:cNvPr id="10" name="Image 1" descr="preencoded.png"/>
           <p:cNvPicPr>
             <a:picLocks noChangeAspect="1"/>
           </p:cNvPicPr>
@@ -7031,7 +7031,7 @@
       </p:sp>
       <p:pic>
         <p:nvPicPr>
-          <p:cNvPr id="12" name="Image 2" descr="preencoded.png">    </p:cNvPr>
+          <p:cNvPr id="12" name="Image 2" descr="preencoded.png"/>
           <p:cNvPicPr>
             <a:picLocks noChangeAspect="1"/>
           </p:cNvPicPr>
@@ -7202,7 +7202,7 @@
       </p:sp>
       <p:pic>
         <p:nvPicPr>
-          <p:cNvPr id="17" name="Image 3" descr="preencoded.png">    </p:cNvPr>
+          <p:cNvPr id="17" name="Image 3" descr="preencoded.png"/>
           <p:cNvPicPr>
             <a:picLocks noChangeAspect="1"/>
           </p:cNvPicPr>
@@ -7257,7 +7257,7 @@
       </p:sp>
       <p:pic>
         <p:nvPicPr>
-          <p:cNvPr id="19" name="Image 4" descr="preencoded.png">    </p:cNvPr>
+          <p:cNvPr id="19" name="Image 4" descr="preencoded.png"/>
           <p:cNvPicPr>
             <a:picLocks noChangeAspect="1"/>
           </p:cNvPicPr>
@@ -7428,7 +7428,7 @@
       </p:sp>
       <p:pic>
         <p:nvPicPr>
-          <p:cNvPr id="24" name="Image 5" descr="preencoded.png">    </p:cNvPr>
+          <p:cNvPr id="24" name="Image 5" descr="preencoded.png"/>
           <p:cNvPicPr>
             <a:picLocks noChangeAspect="1"/>
           </p:cNvPicPr>
@@ -7483,7 +7483,7 @@
       </p:sp>
       <p:pic>
         <p:nvPicPr>
-          <p:cNvPr id="26" name="Image 6" descr="preencoded.png">    </p:cNvPr>
+          <p:cNvPr id="26" name="Image 6" descr="preencoded.png"/>
           <p:cNvPicPr>
             <a:picLocks noChangeAspect="1"/>
           </p:cNvPicPr>
@@ -7836,7 +7836,7 @@
                 <a:ea typeface="JetBrains Mono" pitchFamily="34" charset="-122"/>
                 <a:cs typeface="JetBrains Mono" pitchFamily="34" charset="-120"/>
               </a:rPr>
-              <a:t>   Los playbooks</a:t>
+              <a:t xml:space="preserve">   Los playbooks</a:t>
             </a:r>
             <a:endParaRPr lang="en-US" sz="1200" dirty="0"/>
           </a:p>
@@ -9241,7 +9241,7 @@
                 <a:ea typeface="JetBrains Mono" pitchFamily="34" charset="-122"/>
                 <a:cs typeface="JetBrains Mono" pitchFamily="34" charset="-120"/>
               </a:rPr>
-              <a:t>   El Council</a:t>
+              <a:t xml:space="preserve">   El Council</a:t>
             </a:r>
             <a:endParaRPr lang="en-US" sz="1200" dirty="0"/>
           </a:p>
@@ -9602,7 +9602,7 @@
       </p:sp>
       <p:pic>
         <p:nvPicPr>
-          <p:cNvPr id="12" name="Image 0" descr="preencoded.png">    </p:cNvPr>
+          <p:cNvPr id="12" name="Image 0" descr="preencoded.png"/>
           <p:cNvPicPr>
             <a:picLocks noChangeAspect="1"/>
           </p:cNvPicPr>
@@ -9694,7 +9694,7 @@
       </p:sp>
       <p:pic>
         <p:nvPicPr>
-          <p:cNvPr id="15" name="Image 1" descr="preencoded.png">    </p:cNvPr>
+          <p:cNvPr id="15" name="Image 1" descr="preencoded.png"/>
           <p:cNvPicPr>
             <a:picLocks noChangeAspect="1"/>
           </p:cNvPicPr>
@@ -9786,7 +9786,7 @@
       </p:sp>
       <p:pic>
         <p:nvPicPr>
-          <p:cNvPr id="18" name="Image 2" descr="preencoded.png">    </p:cNvPr>
+          <p:cNvPr id="18" name="Image 2" descr="preencoded.png"/>
           <p:cNvPicPr>
             <a:picLocks noChangeAspect="1"/>
           </p:cNvPicPr>
@@ -9880,7 +9880,7 @@
       </p:sp>
       <p:pic>
         <p:nvPicPr>
-          <p:cNvPr id="21" name="Image 3" descr="preencoded.png">    </p:cNvPr>
+          <p:cNvPr id="21" name="Image 3" descr="preencoded.png"/>
           <p:cNvPicPr>
             <a:picLocks noChangeAspect="1"/>
           </p:cNvPicPr>
@@ -10167,7 +10167,7 @@
                 <a:ea typeface="JetBrains Mono" pitchFamily="34" charset="-122"/>
                 <a:cs typeface="JetBrains Mono" pitchFamily="34" charset="-120"/>
               </a:rPr>
-              <a:t>   Higiene de código</a:t>
+              <a:t xml:space="preserve">   Higiene de código</a:t>
             </a:r>
             <a:endParaRPr lang="en-US" sz="1200" dirty="0"/>
           </a:p>
@@ -11437,7 +11437,7 @@
                 <a:ea typeface="JetBrains Mono" pitchFamily="34" charset="-122"/>
                 <a:cs typeface="JetBrains Mono" pitchFamily="34" charset="-120"/>
               </a:rPr>
-              <a:t>   Cómo pedir bien</a:t>
+              <a:t xml:space="preserve">   Cómo pedir bien</a:t>
             </a:r>
             <a:endParaRPr lang="en-US" sz="1200" dirty="0"/>
           </a:p>
@@ -12687,7 +12687,7 @@
                 <a:ea typeface="JetBrains Mono" pitchFamily="34" charset="-122"/>
                 <a:cs typeface="JetBrains Mono" pitchFamily="34" charset="-120"/>
               </a:rPr>
-              <a:t>   Demo</a:t>
+              <a:t xml:space="preserve">   Demo</a:t>
             </a:r>
             <a:endParaRPr lang="en-US" sz="1200" dirty="0"/>
           </a:p>

</xml_diff>

<commit_message>
docs: deck y guion a 8 skills + dos hooks + URL real; refresca CONTINUAR
Co-Authored-By: Claude Fable 5 <noreply@anthropic.com>
</commit_message>
<xml_diff>
--- a/presentacion/kit-chema.pptx
+++ b/presentacion/kit-chema.pptx
@@ -2339,7 +2339,7 @@
                 <a:ea typeface="JetBrains Mono" pitchFamily="34" charset="-122"/>
                 <a:cs typeface="JetBrains Mono" pitchFamily="34" charset="-120"/>
               </a:rPr>
-              <a:t xml:space="preserve">$ </a:t>
+              <a:t xml:space="preserve">$ git clone https://github.com/chemaw8/claude-kit-chema.git claude-kit-chema</a:t>
             </a:r>
             <a:pPr algn="l" indent="0" marL="0">
               <a:buNone/>
@@ -2353,7 +2353,7 @@
                 <a:ea typeface="JetBrains Mono" pitchFamily="34" charset="-122"/>
                 <a:cs typeface="JetBrains Mono" pitchFamily="34" charset="-120"/>
               </a:rPr>
-              <a:t>git clone &lt;url&gt; claude-kit-chema</a:t>
+              <a:t/>
             </a:r>
             <a:endParaRPr lang="en-US" sz="1350" dirty="0"/>
           </a:p>
@@ -2731,7 +2731,7 @@
                 <a:ea typeface="Inter" pitchFamily="34" charset="-122"/>
                 <a:cs typeface="Inter" pitchFamily="34" charset="-120"/>
               </a:rPr>
-              <a:t>Hook opt-in</a:t>
+              <a:t>Hooks</a:t>
             </a:r>
             <a:endParaRPr lang="en-US" sz="1500" dirty="0"/>
           </a:p>
@@ -2773,7 +2773,7 @@
                 <a:ea typeface="Inter" pitchFamily="34" charset="-122"/>
                 <a:cs typeface="Inter" pitchFamily="34" charset="-120"/>
               </a:rPr>
-              <a:t>Actívalo con KIT_HOOKS=s ./instalar.sh para bloquear commits con secretos.</a:t>
+              <a:t>El de contexto se instala por defecto; el anti-secretos es opt-in con KIT_HOOKS=s ./instalar.sh.</a:t>
             </a:r>
             <a:endParaRPr lang="en-US" sz="1250" dirty="0"/>
           </a:p>
@@ -6190,7 +6190,7 @@
                 <a:ea typeface="Inter" pitchFamily="34" charset="-122"/>
                 <a:cs typeface="Inter" pitchFamily="34" charset="-120"/>
               </a:rPr>
-              <a:t>7 skills de dominio que se activan solas cuando la tarea las necesita.</a:t>
+              <a:t>8 skills de dominio que se activan solas cuando la tarea las necesita.</a:t>
             </a:r>
             <a:endParaRPr lang="en-US" sz="1350" dirty="0"/>
           </a:p>
@@ -6320,7 +6320,7 @@
                 <a:ea typeface="Inter" pitchFamily="34" charset="-122"/>
                 <a:cs typeface="Inter" pitchFamily="34" charset="-120"/>
               </a:rPr>
-              <a:t>Hook anti-secretos</a:t>
+              <a:t>Dos hooks</a:t>
             </a:r>
             <a:endParaRPr lang="en-US" sz="1900" dirty="0"/>
           </a:p>
@@ -6362,7 +6362,7 @@
                 <a:ea typeface="Inter" pitchFamily="34" charset="-122"/>
                 <a:cs typeface="Inter" pitchFamily="34" charset="-120"/>
               </a:rPr>
-              <a:t>Regla determinista opt-in que ejecuta la máquina, no la memoria de Claude.</a:t>
+              <a:t>Contexto (autocarga tu perfil) y anti-secretos (bloquea credenciales): reglas que ejecuta la máquina, no la memoria.</a:t>
             </a:r>
             <a:endParaRPr lang="en-US" sz="1350" dirty="0"/>
           </a:p>
@@ -7878,7 +7878,7 @@
                 <a:ea typeface="Inter" pitchFamily="34" charset="-122"/>
                 <a:cs typeface="Inter" pitchFamily="34" charset="-120"/>
               </a:rPr>
-              <a:t>Siete playbooks: cada dominio con lo que garantiza</a:t>
+              <a:t>Ocho playbooks: cada dominio con lo que garantiza</a:t>
             </a:r>
             <a:endParaRPr lang="en-US" sz="3000" dirty="0"/>
           </a:p>
@@ -9014,6 +9014,144 @@
                   </a:tcPr>
                 </a:tc>
               </a:tr>
+              <a:tr h="484632">
+                <a:tc>
+                  <a:txBody>
+                    <a:bodyPr/>
+                    <a:lstStyle/>
+                    <a:p>
+                      <a:pPr algn="l" indent="0" marL="0">
+                        <a:buNone/>
+                      </a:pPr>
+                      <a:r>
+                        <a:rPr lang="en-US" sz="1300" b="1" dirty="0">
+                          <a:solidFill>
+                            <a:srgbClr val="105687"/>
+                          </a:solidFill>
+                          <a:latin typeface="Inter" pitchFamily="34" charset="0"/>
+                          <a:ea typeface="Inter" pitchFamily="34" charset="-122"/>
+                          <a:cs typeface="Inter" pitchFamily="34" charset="-120"/>
+                        </a:rPr>
+                        <a:t>Redacción</a:t>
+                      </a:r>
+                      <a:endParaRPr lang="en-US" sz="1300" dirty="0">
+                        <a:latin typeface="Inter" charset="0"/>
+                        <a:ea typeface="Inter" charset="0"/>
+                        <a:cs typeface="Inter" charset="0"/>
+                      </a:endParaRPr>
+                    </a:p>
+                  </a:txBody>
+                  <a:tcPr marL="101600" marR="101600" marT="50800" marB="50800" anchor="ctr">
+                    <a:lnL w="12700" cap="flat" cmpd="sng" algn="ctr">
+                      <a:solidFill>
+                        <a:srgbClr val="DCE4EA"/>
+                      </a:solidFill>
+                      <a:prstDash val="solid"/>
+                      <a:round/>
+                      <a:headEnd type="none" w="med" len="med"/>
+                      <a:tailEnd type="none" w="med" len="med"/>
+                    </a:lnL>
+                    <a:lnR w="12700" cap="flat" cmpd="sng" algn="ctr">
+                      <a:solidFill>
+                        <a:srgbClr val="DCE4EA"/>
+                      </a:solidFill>
+                      <a:prstDash val="solid"/>
+                      <a:round/>
+                      <a:headEnd type="none" w="med" len="med"/>
+                      <a:tailEnd type="none" w="med" len="med"/>
+                    </a:lnR>
+                    <a:lnT w="12700" cap="flat" cmpd="sng" algn="ctr">
+                      <a:solidFill>
+                        <a:srgbClr val="DCE4EA"/>
+                      </a:solidFill>
+                      <a:prstDash val="solid"/>
+                      <a:round/>
+                      <a:headEnd type="none" w="med" len="med"/>
+                      <a:tailEnd type="none" w="med" len="med"/>
+                    </a:lnT>
+                    <a:lnB w="12700" cap="flat" cmpd="sng" algn="ctr">
+                      <a:solidFill>
+                        <a:srgbClr val="DCE4EA"/>
+                      </a:solidFill>
+                      <a:prstDash val="solid"/>
+                      <a:round/>
+                      <a:headEnd type="none" w="med" len="med"/>
+                      <a:tailEnd type="none" w="med" len="med"/>
+                    </a:lnB>
+                    <a:solidFill>
+                      <a:srgbClr val="FFFFFF"/>
+                    </a:solidFill>
+                  </a:tcPr>
+                </a:tc>
+                <a:tc>
+                  <a:txBody>
+                    <a:bodyPr/>
+                    <a:lstStyle/>
+                    <a:p>
+                      <a:pPr algn="l" indent="0" marL="0">
+                        <a:buNone/>
+                      </a:pPr>
+                      <a:r>
+                        <a:rPr lang="en-US" sz="1250" dirty="0">
+                          <a:solidFill>
+                            <a:srgbClr val="36434E"/>
+                          </a:solidFill>
+                          <a:latin typeface="Inter" pitchFamily="34" charset="0"/>
+                          <a:ea typeface="Inter" pitchFamily="34" charset="-122"/>
+                          <a:cs typeface="Inter" pitchFamily="34" charset="-120"/>
+                        </a:rPr>
+                        <a:t>correo con pedido claro; minuta con acuerdos, responsables y fechas; sin invadir deck ni propuesta</a:t>
+                      </a:r>
+                      <a:endParaRPr lang="en-US" sz="1250" dirty="0">
+                        <a:latin typeface="Inter" charset="0"/>
+                        <a:ea typeface="Inter" charset="0"/>
+                        <a:cs typeface="Inter" charset="0"/>
+                      </a:endParaRPr>
+                    </a:p>
+                  </a:txBody>
+                  <a:tcPr marL="101600" marR="101600" marT="50800" marB="50800" anchor="ctr">
+                    <a:lnL w="12700" cap="flat" cmpd="sng" algn="ctr">
+                      <a:solidFill>
+                        <a:srgbClr val="DCE4EA"/>
+                      </a:solidFill>
+                      <a:prstDash val="solid"/>
+                      <a:round/>
+                      <a:headEnd type="none" w="med" len="med"/>
+                      <a:tailEnd type="none" w="med" len="med"/>
+                    </a:lnL>
+                    <a:lnR w="12700" cap="flat" cmpd="sng" algn="ctr">
+                      <a:solidFill>
+                        <a:srgbClr val="DCE4EA"/>
+                      </a:solidFill>
+                      <a:prstDash val="solid"/>
+                      <a:round/>
+                      <a:headEnd type="none" w="med" len="med"/>
+                      <a:tailEnd type="none" w="med" len="med"/>
+                    </a:lnR>
+                    <a:lnT w="12700" cap="flat" cmpd="sng" algn="ctr">
+                      <a:solidFill>
+                        <a:srgbClr val="DCE4EA"/>
+                      </a:solidFill>
+                      <a:prstDash val="solid"/>
+                      <a:round/>
+                      <a:headEnd type="none" w="med" len="med"/>
+                      <a:tailEnd type="none" w="med" len="med"/>
+                    </a:lnT>
+                    <a:lnB w="12700" cap="flat" cmpd="sng" algn="ctr">
+                      <a:solidFill>
+                        <a:srgbClr val="DCE4EA"/>
+                      </a:solidFill>
+                      <a:prstDash val="solid"/>
+                      <a:round/>
+                      <a:headEnd type="none" w="med" len="med"/>
+                      <a:tailEnd type="none" w="med" len="med"/>
+                    </a:lnB>
+                    <a:solidFill>
+                      <a:srgbClr val="FFFFFF"/>
+                    </a:solidFill>
+                  </a:tcPr>
+                </a:tc>
+              </a:tr>
             </a:tbl>
           </a:graphicData>
         </a:graphic>

</xml_diff>

<commit_message>
docs(deck): sello a v1.8 y vía real de claude.ai en lámina 10
El sello de portada decía v1.0·2026-07-09 y la lámina de instalación enseñaba
el método degradado de claude.ai (pegar/subir archivos) que v1.7 corrigió: las
skills se suben como zip con disparo automático. Guion sincronizado.

Co-Authored-By: Claude Opus 4.8 (1M context) <noreply@anthropic.com>
</commit_message>
<xml_diff>
--- a/presentacion/kit-chema.pptx
+++ b/presentacion/kit-chema.pptx
@@ -2070,7 +2070,7 @@
                 <a:ea typeface="JetBrains Mono" pitchFamily="34" charset="-122"/>
                 <a:cs typeface="JetBrains Mono" pitchFamily="34" charset="-120"/>
               </a:rPr>
-              <a:t>repositorio claude-kit-chema   ·   v1.0   ·   2026-07-09</a:t>
+              <a:t>repositorio claude-kit-chema   ·   v1.8   ·   2026-07-11</a:t>
             </a:r>
             <a:endParaRPr lang="en-US" sz="1100" dirty="0"/>
           </a:p>
@@ -2909,7 +2909,7 @@
                 <a:ea typeface="Inter" pitchFamily="34" charset="-122"/>
                 <a:cs typeface="Inter" pitchFamily="34" charset="-120"/>
               </a:rPr>
-              <a:t>Pega el núcleo como instrucciones del proyecto y sube los SKILL.md que uses.</a:t>
+              <a:t>Las skills se suben como zip (Settings → Capabilities) y disparan solas; el núcleo se pega como instrucciones del proyecto.</a:t>
             </a:r>
             <a:endParaRPr lang="en-US" sz="1250" dirty="0"/>
           </a:p>

</xml_diff>

<commit_message>
docs(deck): lámina 13 'El ecosistema' — stack completo y compatibilidad
Kit Chema como principal + superpowers + find-skills + añadibles evaluadas
(document-skills, security-guidance, pr-review-toolkit, commit-commands), con
la línea de carriles. Footers de las 12 láminas previas a '/ 13'. Guion
sincronizado.

Co-Authored-By: Claude Opus 4.8 (1M context) <noreply@anthropic.com>
</commit_message>
<xml_diff>
--- a/presentacion/kit-chema.pptx
+++ b/presentacion/kit-chema.pptx
@@ -17,6 +17,7 @@
     <p:sldId id="265" r:id="rId11"/>
     <p:sldId id="266" r:id="rId12"/>
     <p:sldId id="267" r:id="rId13"/>
+    <p:sldId id="268" r:id="rId19"/>
   </p:sldIdLst>
   <p:notesMasterIdLst>
     <p:notesMasterId r:id="rId14"/>
@@ -3014,7 +3015,7 @@
                 <a:ea typeface="JetBrains Mono" pitchFamily="34" charset="-122"/>
                 <a:cs typeface="JetBrains Mono" pitchFamily="34" charset="-120"/>
               </a:rPr>
-              <a:t>10 / 12</a:t>
+              <a:t>10 / 13</a:t>
             </a:r>
             <a:endParaRPr lang="en-US" sz="900" dirty="0"/>
           </a:p>
@@ -3835,7 +3836,7 @@
                 <a:ea typeface="JetBrains Mono" pitchFamily="34" charset="-122"/>
                 <a:cs typeface="JetBrains Mono" pitchFamily="34" charset="-120"/>
               </a:rPr>
-              <a:t>11 / 12</a:t>
+              <a:t>11 / 13</a:t>
             </a:r>
             <a:endParaRPr lang="en-US" sz="900" dirty="0"/>
           </a:p>
@@ -4557,7 +4558,642 @@
                 <a:ea typeface="JetBrains Mono" pitchFamily="34" charset="-122"/>
                 <a:cs typeface="JetBrains Mono" pitchFamily="34" charset="-120"/>
               </a:rPr>
-              <a:t>12 / 12</a:t>
+              <a:t>12 / 13</a:t>
+            </a:r>
+            <a:endParaRPr lang="en-US" sz="900" dirty="0"/>
+          </a:p>
+        </p:txBody>
+      </p:sp>
+    </p:spTree>
+  </p:cSld>
+  <p:clrMapOvr>
+    <a:masterClrMapping/>
+  </p:clrMapOvr>
+</p:sld>
+</file>
+
+<file path=ppt/slides/slide13.xml><?xml version="1.0" encoding="utf-8"?>
+<p:sld xmlns:a="http://schemas.openxmlformats.org/drawingml/2006/main" xmlns:p="http://schemas.openxmlformats.org/presentationml/2006/main" xmlns:r="http://schemas.openxmlformats.org/officeDocument/2006/relationships">
+  <p:cSld>
+    <p:spTree>
+      <p:nvGrpSpPr>
+        <p:cNvPr id="1" name=""/>
+        <p:cNvGrpSpPr/>
+        <p:nvPr/>
+      </p:nvGrpSpPr>
+      <p:grpSpPr/>
+      <p:sp>
+        <p:nvSpPr>
+          <p:cNvPr id="2" name="Text 0"/>
+          <p:cNvSpPr/>
+          <p:nvPr/>
+        </p:nvSpPr>
+        <p:spPr>
+          <a:xfrm>
+            <a:off x="640080" y="457200"/>
+            <a:ext cx="10911535" cy="320040"/>
+          </a:xfrm>
+          <a:prstGeom prst="rect">
+            <a:avLst/>
+          </a:prstGeom>
+          <a:noFill/>
+          <a:ln/>
+        </p:spPr>
+        <p:txBody>
+          <a:bodyPr wrap="square" lIns="0" tIns="0" rIns="0" bIns="0" rtlCol="0" anchor="ctr"/>
+          <a:lstStyle/>
+          <a:p>
+            <a:pPr algn="l" indent="0" marL="0">
+              <a:buNone/>
+            </a:pPr>
+            <a:r>
+              <a:rPr lang="en-US" sz="1200" b="1" spc="100" kern="0" dirty="0">
+                <a:solidFill>
+                  <a:srgbClr val="DD8533"/>
+                </a:solidFill>
+                <a:latin typeface="JetBrains Mono" pitchFamily="34" charset="0"/>
+                <a:ea typeface="JetBrains Mono" pitchFamily="34" charset="-122"/>
+                <a:cs typeface="JetBrains Mono" pitchFamily="34" charset="-120"/>
+              </a:rPr>
+              <a:t>13   El ecosistema</a:t>
+            </a:r>
+            <a:pPr algn="l" indent="0" marL="0">
+              <a:buNone/>
+            </a:pPr>
+            <a:r>
+              <a:rPr lang="en-US" sz="1200" spc="100" kern="0" dirty="0">
+                <a:solidFill>
+                  <a:srgbClr val="8A99A6"/>
+                </a:solidFill>
+                <a:latin typeface="JetBrains Mono" pitchFamily="34" charset="0"/>
+                <a:ea typeface="JetBrains Mono" pitchFamily="34" charset="-122"/>
+                <a:cs typeface="JetBrains Mono" pitchFamily="34" charset="-120"/>
+              </a:rPr>
+              <a:t xml:space="preserve"/>
+            </a:r>
+            <a:endParaRPr lang="en-US" sz="1200" dirty="0"/>
+          </a:p>
+        </p:txBody>
+      </p:sp>
+      <p:sp>
+        <p:nvSpPr>
+          <p:cNvPr id="3" name="Text 1"/>
+          <p:cNvSpPr/>
+          <p:nvPr/>
+        </p:nvSpPr>
+        <p:spPr>
+          <a:xfrm>
+            <a:off x="640080" y="822960"/>
+            <a:ext cx="10911535" cy="914400"/>
+          </a:xfrm>
+          <a:prstGeom prst="rect">
+            <a:avLst/>
+          </a:prstGeom>
+          <a:noFill/>
+          <a:ln/>
+        </p:spPr>
+        <p:txBody>
+          <a:bodyPr wrap="square" lIns="0" tIns="0" rIns="0" bIns="0" rtlCol="0" anchor="t"/>
+          <a:lstStyle/>
+          <a:p>
+            <a:pPr algn="l" indent="0" marL="0">
+              <a:lnSpc>
+                <a:spcPts val="3200"/>
+              </a:lnSpc>
+              <a:buNone/>
+            </a:pPr>
+            <a:r>
+              <a:rPr lang="en-US" sz="3000" b="1" dirty="0">
+                <a:solidFill>
+                  <a:srgbClr val="105687"/>
+                </a:solidFill>
+                <a:latin typeface="Inter" pitchFamily="34" charset="0"/>
+                <a:ea typeface="Inter" pitchFamily="34" charset="-122"/>
+                <a:cs typeface="Inter" pitchFamily="34" charset="-120"/>
+              </a:rPr>
+              <a:t>El kit no está solo: el stack completo, probado junto</a:t>
+            </a:r>
+            <a:endParaRPr lang="en-US" sz="3000" dirty="0"/>
+          </a:p>
+        </p:txBody>
+      </p:sp>
+      <p:sp>
+        <p:nvSpPr>
+          <p:cNvPr id="8" name="Text 5"/>
+          <p:cNvSpPr/>
+          <p:nvPr/>
+        </p:nvSpPr>
+        <p:spPr>
+          <a:xfrm>
+            <a:off x="640080" y="3200400"/>
+            <a:ext cx="2384984" cy="548640"/>
+          </a:xfrm>
+          <a:prstGeom prst="rect">
+            <a:avLst/>
+          </a:prstGeom>
+          <a:noFill/>
+          <a:ln/>
+        </p:spPr>
+        <p:txBody>
+          <a:bodyPr wrap="square" lIns="0" tIns="0" rIns="0" bIns="0" rtlCol="0" anchor="t"/>
+          <a:lstStyle/>
+          <a:p>
+            <a:pPr algn="ctr" indent="0" marL="0">
+              <a:lnSpc>
+                <a:spcPts val="1700"/>
+              </a:lnSpc>
+              <a:buNone/>
+            </a:pPr>
+            <a:r>
+              <a:rPr lang="en-US" sz="1500" b="1" dirty="0">
+                <a:solidFill>
+                  <a:srgbClr val="1A1D21"/>
+                </a:solidFill>
+                <a:latin typeface="Inter" pitchFamily="34" charset="0"/>
+                <a:ea typeface="Inter" pitchFamily="34" charset="-122"/>
+                <a:cs typeface="Inter" pitchFamily="34" charset="-120"/>
+              </a:rPr>
+              <a:t>Kit Chema — el principal</a:t>
+            </a:r>
+            <a:endParaRPr lang="en-US" sz="1500" dirty="0"/>
+          </a:p>
+        </p:txBody>
+      </p:sp>
+      <p:sp>
+        <p:nvSpPr>
+          <p:cNvPr id="9" name="Text 6"/>
+          <p:cNvSpPr/>
+          <p:nvPr/>
+        </p:nvSpPr>
+        <p:spPr>
+          <a:xfrm>
+            <a:off x="640080" y="3776472"/>
+            <a:ext cx="2384984" cy="1463040"/>
+          </a:xfrm>
+          <a:prstGeom prst="rect">
+            <a:avLst/>
+          </a:prstGeom>
+          <a:noFill/>
+          <a:ln/>
+        </p:spPr>
+        <p:txBody>
+          <a:bodyPr wrap="square" lIns="0" tIns="0" rIns="0" bIns="0" rtlCol="0" anchor="t"/>
+          <a:lstStyle/>
+          <a:p>
+            <a:pPr algn="ctr" indent="0" marL="0">
+              <a:lnSpc>
+                <a:spcPts val="1700"/>
+              </a:lnSpc>
+              <a:buNone/>
+            </a:pPr>
+            <a:r>
+              <a:rPr lang="en-US" sz="1250" dirty="0">
+                <a:solidFill>
+                  <a:srgbClr val="44515C"/>
+                </a:solidFill>
+                <a:latin typeface="Inter" pitchFamily="34" charset="0"/>
+                <a:ea typeface="Inter" pitchFamily="34" charset="-122"/>
+                <a:cs typeface="Inter" pitchFamily="34" charset="-120"/>
+              </a:rPr>
+              <a:t>Criterio y calidad en 8 dominios; gobernado por council, CI y branch protection. Todo lo demás se acomoda a su alrededor.</a:t>
+            </a:r>
+            <a:endParaRPr lang="en-US" sz="1250" dirty="0"/>
+          </a:p>
+        </p:txBody>
+      </p:sp>
+      <p:sp>
+        <p:nvSpPr>
+          <p:cNvPr id="15" name="Text 10"/>
+          <p:cNvSpPr/>
+          <p:nvPr/>
+        </p:nvSpPr>
+        <p:spPr>
+          <a:xfrm>
+            <a:off x="3482264" y="3200400"/>
+            <a:ext cx="2384984" cy="548640"/>
+          </a:xfrm>
+          <a:prstGeom prst="rect">
+            <a:avLst/>
+          </a:prstGeom>
+          <a:noFill/>
+          <a:ln/>
+        </p:spPr>
+        <p:txBody>
+          <a:bodyPr wrap="square" lIns="0" tIns="0" rIns="0" bIns="0" rtlCol="0" anchor="t"/>
+          <a:lstStyle/>
+          <a:p>
+            <a:pPr algn="ctr" indent="0" marL="0">
+              <a:lnSpc>
+                <a:spcPts val="1700"/>
+              </a:lnSpc>
+              <a:buNone/>
+            </a:pPr>
+            <a:r>
+              <a:rPr lang="en-US" sz="1500" b="1" dirty="0">
+                <a:solidFill>
+                  <a:srgbClr val="1A1D21"/>
+                </a:solidFill>
+                <a:latin typeface="Inter" pitchFamily="34" charset="0"/>
+                <a:ea typeface="Inter" pitchFamily="34" charset="-122"/>
+                <a:cs typeface="Inter" pitchFamily="34" charset="-120"/>
+              </a:rPr>
+              <a:t>superpowers (MIT)</a:t>
+            </a:r>
+            <a:endParaRPr lang="en-US" sz="1500" dirty="0"/>
+          </a:p>
+        </p:txBody>
+      </p:sp>
+      <p:sp>
+        <p:nvSpPr>
+          <p:cNvPr id="16" name="Text 11"/>
+          <p:cNvSpPr/>
+          <p:nvPr/>
+        </p:nvSpPr>
+        <p:spPr>
+          <a:xfrm>
+            <a:off x="3482264" y="3776472"/>
+            <a:ext cx="2384984" cy="1463040"/>
+          </a:xfrm>
+          <a:prstGeom prst="rect">
+            <a:avLst/>
+          </a:prstGeom>
+          <a:noFill/>
+          <a:ln/>
+        </p:spPr>
+        <p:txBody>
+          <a:bodyPr wrap="square" lIns="0" tIns="0" rIns="0" bIns="0" rtlCol="0" anchor="t"/>
+          <a:lstStyle/>
+          <a:p>
+            <a:pPr algn="ctr" indent="0" marL="0">
+              <a:lnSpc>
+                <a:spcPts val="1700"/>
+              </a:lnSpc>
+              <a:buNone/>
+            </a:pPr>
+            <a:r>
+              <a:rPr lang="en-US" sz="1250" dirty="0">
+                <a:solidFill>
+                  <a:srgbClr val="44515C"/>
+                </a:solidFill>
+                <a:latin typeface="Inter" pitchFamily="34" charset="0"/>
+                <a:ea typeface="Inter" pitchFamily="34" charset="-122"/>
+                <a:cs typeface="Inter" pitchFamily="34" charset="-120"/>
+              </a:rPr>
+              <a:t>Metodología de desarrollo: brainstorming, planes, TDD, debugging. Compatible: kit-codigo trae el bloque que reparte los carriles.</a:t>
+            </a:r>
+            <a:endParaRPr lang="en-US" sz="1250" dirty="0"/>
+          </a:p>
+        </p:txBody>
+      </p:sp>
+      <p:sp>
+        <p:nvSpPr>
+          <p:cNvPr id="22" name="Text 15"/>
+          <p:cNvSpPr/>
+          <p:nvPr/>
+        </p:nvSpPr>
+        <p:spPr>
+          <a:xfrm>
+            <a:off x="6324448" y="3200400"/>
+            <a:ext cx="2384984" cy="548640"/>
+          </a:xfrm>
+          <a:prstGeom prst="rect">
+            <a:avLst/>
+          </a:prstGeom>
+          <a:noFill/>
+          <a:ln/>
+        </p:spPr>
+        <p:txBody>
+          <a:bodyPr wrap="square" lIns="0" tIns="0" rIns="0" bIns="0" rtlCol="0" anchor="t"/>
+          <a:lstStyle/>
+          <a:p>
+            <a:pPr algn="ctr" indent="0" marL="0">
+              <a:lnSpc>
+                <a:spcPts val="1700"/>
+              </a:lnSpc>
+              <a:buNone/>
+            </a:pPr>
+            <a:r>
+              <a:rPr lang="en-US" sz="1500" b="1" dirty="0">
+                <a:solidFill>
+                  <a:srgbClr val="1A1D21"/>
+                </a:solidFill>
+                <a:latin typeface="Inter" pitchFamily="34" charset="0"/>
+                <a:ea typeface="Inter" pitchFamily="34" charset="-122"/>
+                <a:cs typeface="Inter" pitchFamily="34" charset="-120"/>
+              </a:rPr>
+              <a:t>find-skills</a:t>
+            </a:r>
+            <a:endParaRPr lang="en-US" sz="1500" dirty="0"/>
+          </a:p>
+        </p:txBody>
+      </p:sp>
+      <p:sp>
+        <p:nvSpPr>
+          <p:cNvPr id="23" name="Text 16"/>
+          <p:cNvSpPr/>
+          <p:nvPr/>
+        </p:nvSpPr>
+        <p:spPr>
+          <a:xfrm>
+            <a:off x="6324448" y="3776472"/>
+            <a:ext cx="2384984" cy="1463040"/>
+          </a:xfrm>
+          <a:prstGeom prst="rect">
+            <a:avLst/>
+          </a:prstGeom>
+          <a:noFill/>
+          <a:ln/>
+        </p:spPr>
+        <p:txBody>
+          <a:bodyPr wrap="square" lIns="0" tIns="0" rIns="0" bIns="0" rtlCol="0" anchor="t"/>
+          <a:lstStyle/>
+          <a:p>
+            <a:pPr algn="ctr" indent="0" marL="0">
+              <a:lnSpc>
+                <a:spcPts val="1700"/>
+              </a:lnSpc>
+              <a:buNone/>
+            </a:pPr>
+            <a:r>
+              <a:rPr lang="en-US" sz="1250" dirty="0">
+                <a:solidFill>
+                  <a:srgbClr val="44515C"/>
+                </a:solidFill>
+                <a:latin typeface="Inter" pitchFamily="34" charset="0"/>
+                <a:ea typeface="Inter" pitchFamily="34" charset="-122"/>
+                <a:cs typeface="Inter" pitchFamily="34" charset="-120"/>
+              </a:rPr>
+              <a:t>Descubre e instala skills nuevas del ecosistema abierto cuando falta una capacidad — con el presupuesto de disparo en mente.</a:t>
+            </a:r>
+            <a:endParaRPr lang="en-US" sz="1250" dirty="0"/>
+          </a:p>
+        </p:txBody>
+      </p:sp>
+      <p:sp>
+        <p:nvSpPr>
+          <p:cNvPr id="29" name="Text 20"/>
+          <p:cNvSpPr/>
+          <p:nvPr/>
+        </p:nvSpPr>
+        <p:spPr>
+          <a:xfrm>
+            <a:off x="9166631" y="3200400"/>
+            <a:ext cx="2384984" cy="548640"/>
+          </a:xfrm>
+          <a:prstGeom prst="rect">
+            <a:avLst/>
+          </a:prstGeom>
+          <a:noFill/>
+          <a:ln/>
+        </p:spPr>
+        <p:txBody>
+          <a:bodyPr wrap="square" lIns="0" tIns="0" rIns="0" bIns="0" rtlCol="0" anchor="t"/>
+          <a:lstStyle/>
+          <a:p>
+            <a:pPr algn="ctr" indent="0" marL="0">
+              <a:lnSpc>
+                <a:spcPts val="1700"/>
+              </a:lnSpc>
+              <a:buNone/>
+            </a:pPr>
+            <a:r>
+              <a:rPr lang="en-US" sz="1500" b="1" dirty="0">
+                <a:solidFill>
+                  <a:srgbClr val="1A1D21"/>
+                </a:solidFill>
+                <a:latin typeface="Inter" pitchFamily="34" charset="0"/>
+                <a:ea typeface="Inter" pitchFamily="34" charset="-122"/>
+                <a:cs typeface="Inter" pitchFamily="34" charset="-120"/>
+              </a:rPr>
+              <a:t>Añadibles ya evaluadas</a:t>
+            </a:r>
+            <a:endParaRPr lang="en-US" sz="1500" dirty="0"/>
+          </a:p>
+        </p:txBody>
+      </p:sp>
+      <p:sp>
+        <p:nvSpPr>
+          <p:cNvPr id="30" name="Text 21"/>
+          <p:cNvSpPr/>
+          <p:nvPr/>
+        </p:nvSpPr>
+        <p:spPr>
+          <a:xfrm>
+            <a:off x="9166631" y="3776472"/>
+            <a:ext cx="2384984" cy="1463040"/>
+          </a:xfrm>
+          <a:prstGeom prst="rect">
+            <a:avLst/>
+          </a:prstGeom>
+          <a:noFill/>
+          <a:ln/>
+        </p:spPr>
+        <p:txBody>
+          <a:bodyPr wrap="square" lIns="0" tIns="0" rIns="0" bIns="0" rtlCol="0" anchor="t"/>
+          <a:lstStyle/>
+          <a:p>
+            <a:pPr algn="ctr" indent="0" marL="0">
+              <a:lnSpc>
+                <a:spcPts val="1700"/>
+              </a:lnSpc>
+              <a:buNone/>
+            </a:pPr>
+            <a:r>
+              <a:rPr lang="en-US" sz="1250" dirty="0">
+                <a:solidFill>
+                  <a:srgbClr val="44515C"/>
+                </a:solidFill>
+                <a:latin typeface="Inter" pitchFamily="34" charset="0"/>
+                <a:ea typeface="Inter" pitchFamily="34" charset="-122"/>
+                <a:cs typeface="Inter" pitchFamily="34" charset="-120"/>
+              </a:rPr>
+              <a:t>document-skills oficiales (Excel/Word/PDF/PPT con fórmulas vivas), security-guidance (seguridad en cada commit), pr-review-toolkit y commit-commands.</a:t>
+            </a:r>
+            <a:endParaRPr lang="en-US" sz="1250" dirty="0"/>
+          </a:p>
+        </p:txBody>
+      </p:sp>
+      <p:sp>
+        <p:nvSpPr>
+          <p:cNvPr id="17" name="Text 14"/>
+          <p:cNvSpPr/>
+          <p:nvPr/>
+        </p:nvSpPr>
+        <p:spPr>
+          <a:xfrm>
+            <a:off x="640080" y="5212080"/>
+            <a:ext cx="10911535" cy="548640"/>
+          </a:xfrm>
+          <a:prstGeom prst="rect">
+            <a:avLst/>
+          </a:prstGeom>
+          <a:noFill/>
+          <a:ln/>
+        </p:spPr>
+        <p:txBody>
+          <a:bodyPr wrap="square" lIns="0" tIns="0" rIns="0" bIns="0" rtlCol="0" anchor="ctr"/>
+          <a:lstStyle/>
+          <a:p>
+            <a:pPr algn="ctr" indent="0" marL="0">
+              <a:buNone/>
+            </a:pPr>
+            <a:r>
+              <a:rPr lang="en-US" sz="1800" b="1" dirty="0">
+                <a:solidFill>
+                  <a:srgbClr val="FFFFFF"/>
+                </a:solidFill>
+                <a:latin typeface="Inter" pitchFamily="34" charset="0"/>
+                <a:ea typeface="Inter" pitchFamily="34" charset="-122"/>
+                <a:cs typeface="Inter" pitchFamily="34" charset="-120"/>
+              </a:rPr>
+              <a:t xml:space="preserve">Cada capa en su carril: el kit pone el criterio, superpowers el método, los plugins la mecánica — sin choques.</a:t>
+            </a:r>
+            <a:pPr algn="ctr" indent="0" marL="0">
+              <a:buNone/>
+            </a:pPr>
+            <a:r>
+              <a:rPr lang="en-US" sz="1800" dirty="0">
+                <a:solidFill>
+                  <a:srgbClr val="EFA95E"/>
+                </a:solidFill>
+                <a:latin typeface="JetBrains Mono" pitchFamily="34" charset="0"/>
+                <a:ea typeface="JetBrains Mono" pitchFamily="34" charset="-122"/>
+                <a:cs typeface="JetBrains Mono" pitchFamily="34" charset="-120"/>
+              </a:rPr>
+              <a:t/>
+            </a:r>
+            <a:pPr algn="ctr" indent="0" marL="0">
+              <a:buNone/>
+            </a:pPr>
+            <a:r>
+              <a:rPr lang="en-US" sz="1800" dirty="0">
+                <a:solidFill>
+                  <a:srgbClr val="8FA5B5"/>
+                </a:solidFill>
+                <a:latin typeface="Inter" pitchFamily="34" charset="0"/>
+                <a:ea typeface="Inter" pitchFamily="34" charset="-122"/>
+                <a:cs typeface="Inter" pitchFamily="34" charset="-120"/>
+              </a:rPr>
+              <a:t xml:space="preserve"/>
+            </a:r>
+            <a:pPr algn="ctr" indent="0" marL="0">
+              <a:buNone/>
+            </a:pPr>
+            <a:r>
+              <a:rPr lang="en-US" sz="1800" dirty="0">
+                <a:solidFill>
+                  <a:srgbClr val="EFA95E"/>
+                </a:solidFill>
+                <a:latin typeface="JetBrains Mono" pitchFamily="34" charset="0"/>
+                <a:ea typeface="JetBrains Mono" pitchFamily="34" charset="-122"/>
+                <a:cs typeface="JetBrains Mono" pitchFamily="34" charset="-120"/>
+              </a:rPr>
+              <a:t/>
+            </a:r>
+            <a:endParaRPr lang="en-US" sz="1800" dirty="0"/>
+          </a:p>
+        </p:txBody>
+      </p:sp>
+      <p:sp>
+        <p:nvSpPr>
+          <p:cNvPr id="31" name="Shape 22"/>
+          <p:cNvSpPr/>
+          <p:nvPr/>
+        </p:nvSpPr>
+        <p:spPr>
+          <a:xfrm>
+            <a:off x="640080" y="6419088"/>
+            <a:ext cx="10911535" cy="0"/>
+          </a:xfrm>
+          <a:prstGeom prst="line">
+            <a:avLst/>
+          </a:prstGeom>
+          <a:noFill/>
+          <a:ln w="12700">
+            <a:solidFill>
+              <a:srgbClr val="DCE4EA"/>
+            </a:solidFill>
+            <a:prstDash val="solid"/>
+          </a:ln>
+        </p:spPr>
+        <p:txBody>
+          <a:bodyPr/>
+          <a:p/>
+        </p:txBody>
+      </p:sp>
+      <p:sp>
+        <p:nvSpPr>
+          <p:cNvPr id="32" name="Text 23"/>
+          <p:cNvSpPr/>
+          <p:nvPr/>
+        </p:nvSpPr>
+        <p:spPr>
+          <a:xfrm>
+            <a:off x="640080" y="6455664"/>
+            <a:ext cx="3657600" cy="274320"/>
+          </a:xfrm>
+          <a:prstGeom prst="rect">
+            <a:avLst/>
+          </a:prstGeom>
+          <a:noFill/>
+          <a:ln/>
+        </p:spPr>
+        <p:txBody>
+          <a:bodyPr wrap="square" lIns="0" tIns="0" rIns="0" bIns="0" rtlCol="0" anchor="ctr"/>
+          <a:lstStyle/>
+          <a:p>
+            <a:pPr algn="l" indent="0" marL="0">
+              <a:buNone/>
+            </a:pPr>
+            <a:r>
+              <a:rPr lang="en-US" sz="900" dirty="0">
+                <a:solidFill>
+                  <a:srgbClr val="8A99A6"/>
+                </a:solidFill>
+                <a:latin typeface="Inter" pitchFamily="34" charset="0"/>
+                <a:ea typeface="Inter" pitchFamily="34" charset="-122"/>
+                <a:cs typeface="Inter" pitchFamily="34" charset="-120"/>
+              </a:rPr>
+              <a:t>Kit Chema</a:t>
+            </a:r>
+            <a:endParaRPr lang="en-US" sz="900" dirty="0"/>
+          </a:p>
+        </p:txBody>
+      </p:sp>
+      <p:sp>
+        <p:nvSpPr>
+          <p:cNvPr id="33" name="Text 24"/>
+          <p:cNvSpPr/>
+          <p:nvPr/>
+        </p:nvSpPr>
+        <p:spPr>
+          <a:xfrm>
+            <a:off x="9722815" y="6455664"/>
+            <a:ext cx="1828800" cy="274320"/>
+          </a:xfrm>
+          <a:prstGeom prst="rect">
+            <a:avLst/>
+          </a:prstGeom>
+          <a:noFill/>
+          <a:ln/>
+        </p:spPr>
+        <p:txBody>
+          <a:bodyPr wrap="square" lIns="0" tIns="0" rIns="0" bIns="0" rtlCol="0" anchor="ctr"/>
+          <a:lstStyle/>
+          <a:p>
+            <a:pPr algn="r" indent="0" marL="0">
+              <a:buNone/>
+            </a:pPr>
+            <a:r>
+              <a:rPr lang="en-US" sz="900" dirty="0">
+                <a:solidFill>
+                  <a:srgbClr val="8A99A6"/>
+                </a:solidFill>
+                <a:latin typeface="JetBrains Mono" pitchFamily="34" charset="0"/>
+                <a:ea typeface="JetBrains Mono" pitchFamily="34" charset="-122"/>
+                <a:cs typeface="JetBrains Mono" pitchFamily="34" charset="-120"/>
+              </a:rPr>
+              <a:t>13 / 13</a:t>
             </a:r>
             <a:endParaRPr lang="en-US" sz="900" dirty="0"/>
           </a:p>
@@ -5719,7 +6355,7 @@
                 <a:ea typeface="JetBrains Mono" pitchFamily="34" charset="-122"/>
                 <a:cs typeface="JetBrains Mono" pitchFamily="34" charset="-120"/>
               </a:rPr>
-              <a:t>02 / 12</a:t>
+              <a:t>02 / 13</a:t>
             </a:r>
             <a:endParaRPr lang="en-US" sz="900" dirty="0"/>
           </a:p>
@@ -6639,7 +7275,7 @@
                 <a:ea typeface="JetBrains Mono" pitchFamily="34" charset="-122"/>
                 <a:cs typeface="JetBrains Mono" pitchFamily="34" charset="-120"/>
               </a:rPr>
-              <a:t>03 / 12</a:t>
+              <a:t>03 / 13</a:t>
             </a:r>
             <a:endParaRPr lang="en-US" sz="900" dirty="0"/>
           </a:p>
@@ -7751,7 +8387,7 @@
                 <a:ea typeface="JetBrains Mono" pitchFamily="34" charset="-122"/>
                 <a:cs typeface="JetBrains Mono" pitchFamily="34" charset="-120"/>
               </a:rPr>
-              <a:t>04 / 12</a:t>
+              <a:t>04 / 13</a:t>
             </a:r>
             <a:endParaRPr lang="en-US" sz="900" dirty="0"/>
           </a:p>
@@ -9294,7 +9930,7 @@
                 <a:ea typeface="JetBrains Mono" pitchFamily="34" charset="-122"/>
                 <a:cs typeface="JetBrains Mono" pitchFamily="34" charset="-120"/>
               </a:rPr>
-              <a:t>05 / 12</a:t>
+              <a:t>05 / 13</a:t>
             </a:r>
             <a:endParaRPr lang="en-US" sz="900" dirty="0"/>
           </a:p>
@@ -10220,7 +10856,7 @@
                 <a:ea typeface="JetBrains Mono" pitchFamily="34" charset="-122"/>
                 <a:cs typeface="JetBrains Mono" pitchFamily="34" charset="-120"/>
               </a:rPr>
-              <a:t>06 / 12</a:t>
+              <a:t>06 / 13</a:t>
             </a:r>
             <a:endParaRPr lang="en-US" sz="900" dirty="0"/>
           </a:p>
@@ -11490,7 +12126,7 @@
                 <a:ea typeface="JetBrains Mono" pitchFamily="34" charset="-122"/>
                 <a:cs typeface="JetBrains Mono" pitchFamily="34" charset="-120"/>
               </a:rPr>
-              <a:t>07 / 12</a:t>
+              <a:t>07 / 13</a:t>
             </a:r>
             <a:endParaRPr lang="en-US" sz="900" dirty="0"/>
           </a:p>
@@ -12740,7 +13376,7 @@
                 <a:ea typeface="JetBrains Mono" pitchFamily="34" charset="-122"/>
                 <a:cs typeface="JetBrains Mono" pitchFamily="34" charset="-120"/>
               </a:rPr>
-              <a:t>08 / 12</a:t>
+              <a:t>08 / 13</a:t>
             </a:r>
             <a:endParaRPr lang="en-US" sz="900" dirty="0"/>
           </a:p>
@@ -13455,7 +14091,7 @@
                 <a:ea typeface="JetBrains Mono" pitchFamily="34" charset="-122"/>
                 <a:cs typeface="JetBrains Mono" pitchFamily="34" charset="-120"/>
               </a:rPr>
-              <a:t>09 / 12</a:t>
+              <a:t>09 / 13</a:t>
             </a:r>
             <a:endParaRPr lang="en-US" sz="900" dirty="0"/>
           </a:p>

</xml_diff>